<commit_message>
Testing the PPT sharing options
</commit_message>
<xml_diff>
--- a/documentations/SIH.pptx
+++ b/documentations/SIH.pptx
@@ -262,7 +262,7 @@
             <a:fld id="{C4D5ADD5-2BBC-4A94-8F86-D9013941F742}" type="datetimeFigureOut">
               <a:rPr lang="en-US"/>
               <a:pPr/>
-              <a:t>9/7/2026</a:t>
+              <a:t>9/9/2026</a:t>
             </a:fld>
             <a:endParaRPr lang="en-US"/>
           </a:p>
@@ -1713,7 +1713,7 @@
           <a:p>
             <a:fld id="{E60792E3-D524-454C-8AFD-A91972900BCB}" type="datetime1">
               <a:rPr lang="en-US" smtClean="0"/>
-              <a:t>9/7/2026</a:t>
+              <a:t>9/9/2026</a:t>
             </a:fld>
             <a:endParaRPr lang="en-US"/>
           </a:p>
@@ -1895,7 +1895,7 @@
           <a:p>
             <a:fld id="{053C3A68-6922-42D3-8905-ECC2D82A3469}" type="datetime1">
               <a:rPr lang="en-US" smtClean="0"/>
-              <a:t>9/7/2026</a:t>
+              <a:t>9/9/2026</a:t>
             </a:fld>
             <a:endParaRPr lang="en-US"/>
           </a:p>
@@ -2087,7 +2087,7 @@
           <a:p>
             <a:fld id="{CB69E9F4-7604-4950-A8B2-8ACDEDB1506E}" type="datetime1">
               <a:rPr lang="en-US" smtClean="0"/>
-              <a:t>9/7/2026</a:t>
+              <a:t>9/9/2026</a:t>
             </a:fld>
             <a:endParaRPr lang="en-US"/>
           </a:p>
@@ -2269,7 +2269,7 @@
           <a:p>
             <a:fld id="{708B7524-32A2-4C20-A58C-BC3BAA1042FC}" type="datetime1">
               <a:rPr lang="en-US" smtClean="0"/>
-              <a:t>9/7/2026</a:t>
+              <a:t>9/9/2026</a:t>
             </a:fld>
             <a:endParaRPr lang="en-US"/>
           </a:p>
@@ -2528,7 +2528,7 @@
           <a:p>
             <a:fld id="{1E994447-D6B2-43BB-A877-57F1A267B999}" type="datetime1">
               <a:rPr lang="en-US" smtClean="0"/>
-              <a:t>9/7/2026</a:t>
+              <a:t>9/9/2026</a:t>
             </a:fld>
             <a:endParaRPr lang="en-US"/>
           </a:p>
@@ -2827,7 +2827,7 @@
           <a:p>
             <a:fld id="{68920E16-BD35-483C-AA6B-346FC7E46DEA}" type="datetime1">
               <a:rPr lang="en-US" smtClean="0"/>
-              <a:t>9/7/2026</a:t>
+              <a:t>9/9/2026</a:t>
             </a:fld>
             <a:endParaRPr lang="en-US"/>
           </a:p>
@@ -3260,7 +3260,7 @@
           <a:p>
             <a:fld id="{2FEAC6F8-5103-4FC0-A69E-5C6AE6469DA8}" type="datetime1">
               <a:rPr lang="en-US" smtClean="0"/>
-              <a:t>9/7/2026</a:t>
+              <a:t>9/9/2026</a:t>
             </a:fld>
             <a:endParaRPr lang="en-US"/>
           </a:p>
@@ -3391,7 +3391,7 @@
           <a:p>
             <a:fld id="{C60C6921-0627-4C8F-83D5-0CF936D2FFDD}" type="datetime1">
               <a:rPr lang="en-US" smtClean="0"/>
-              <a:t>9/7/2026</a:t>
+              <a:t>9/9/2026</a:t>
             </a:fld>
             <a:endParaRPr lang="en-US"/>
           </a:p>
@@ -3500,7 +3500,7 @@
           <a:p>
             <a:fld id="{2FF08AD7-8103-40F8-983C-E2BA6BB9CBE0}" type="datetime1">
               <a:rPr lang="en-US" smtClean="0"/>
-              <a:t>9/7/2026</a:t>
+              <a:t>9/9/2026</a:t>
             </a:fld>
             <a:endParaRPr lang="en-US"/>
           </a:p>
@@ -3789,7 +3789,7 @@
           <a:p>
             <a:fld id="{DF8C06B4-9380-4A4D-AF49-A3596E17DAF5}" type="datetime1">
               <a:rPr lang="en-US" smtClean="0"/>
-              <a:t>9/7/2026</a:t>
+              <a:t>9/9/2026</a:t>
             </a:fld>
             <a:endParaRPr lang="en-US"/>
           </a:p>
@@ -4058,7 +4058,7 @@
           <a:p>
             <a:fld id="{EF7FDEF1-C582-4E22-9E77-D68326471F28}" type="datetime1">
               <a:rPr lang="en-US" smtClean="0"/>
-              <a:t>9/7/2026</a:t>
+              <a:t>9/9/2026</a:t>
             </a:fld>
             <a:endParaRPr lang="en-US"/>
           </a:p>
@@ -4301,7 +4301,7 @@
           <a:p>
             <a:fld id="{780A9602-A9A9-453F-AEF1-37B5837E02CD}" type="datetime1">
               <a:rPr lang="en-US" smtClean="0"/>
-              <a:t>9/7/2026</a:t>
+              <a:t>9/9/2026</a:t>
             </a:fld>
             <a:endParaRPr lang="en-US"/>
           </a:p>
@@ -6115,7 +6115,7 @@
         <p:spPr bwMode="auto">
           <a:xfrm>
             <a:off x="-1" y="2064921"/>
-            <a:ext cx="12191999" cy="2492990"/>
+            <a:ext cx="12191999" cy="3354765"/>
           </a:xfrm>
           <a:prstGeom prst="rect">
             <a:avLst/>
@@ -6207,6 +6207,29 @@
               </a:rPr>
               <a:t> How it addresses the problem</a:t>
             </a:r>
+          </a:p>
+          <a:p>
+            <a:pPr marL="342900" indent="-342900" algn="just">
+              <a:buFont typeface="Arial" panose="020B0604020202020204" pitchFamily="34" charset="0"/>
+              <a:buChar char="•"/>
+            </a:pPr>
+            <a:r>
+              <a:rPr lang="en-US" sz="2800">
+                <a:latin typeface="Arial" pitchFamily="34" charset="0"/>
+                <a:cs typeface="Arial" pitchFamily="34" charset="0"/>
+              </a:rPr>
+              <a:t>Test 1</a:t>
+            </a:r>
+          </a:p>
+          <a:p>
+            <a:pPr marL="342900" indent="-342900" algn="just">
+              <a:buFont typeface="Arial" panose="020B0604020202020204" pitchFamily="34" charset="0"/>
+              <a:buChar char="•"/>
+            </a:pPr>
+            <a:endParaRPr lang="en-US" sz="2800" dirty="0">
+              <a:latin typeface="Arial" pitchFamily="34" charset="0"/>
+              <a:cs typeface="Arial" pitchFamily="34" charset="0"/>
+            </a:endParaRPr>
           </a:p>
           <a:p>
             <a:pPr marL="342900" indent="-342900" algn="just">

</xml_diff>

<commit_message>
retest for the sharing
</commit_message>
<xml_diff>
--- a/documentations/SIH.pptx
+++ b/documentations/SIH.pptx
@@ -6115,7 +6115,7 @@
         <p:spPr bwMode="auto">
           <a:xfrm>
             <a:off x="-1" y="2064921"/>
-            <a:ext cx="12191999" cy="3354765"/>
+            <a:ext cx="12191999" cy="2492990"/>
           </a:xfrm>
           <a:prstGeom prst="rect">
             <a:avLst/>
@@ -6205,27 +6205,15 @@
                 <a:latin typeface="Arial" pitchFamily="34" charset="0"/>
                 <a:cs typeface="Arial" pitchFamily="34" charset="0"/>
               </a:rPr>
-              <a:t> How it addresses the problem</a:t>
-            </a:r>
-          </a:p>
-          <a:p>
-            <a:pPr marL="342900" indent="-342900" algn="just">
-              <a:buFont typeface="Arial" panose="020B0604020202020204" pitchFamily="34" charset="0"/>
-              <a:buChar char="•"/>
-            </a:pPr>
+              <a:t> How it addresses </a:t>
+            </a:r>
             <a:r>
               <a:rPr lang="en-US" sz="2800">
                 <a:latin typeface="Arial" pitchFamily="34" charset="0"/>
                 <a:cs typeface="Arial" pitchFamily="34" charset="0"/>
               </a:rPr>
-              <a:t>Test 1</a:t>
-            </a:r>
-          </a:p>
-          <a:p>
-            <a:pPr marL="342900" indent="-342900" algn="just">
-              <a:buFont typeface="Arial" panose="020B0604020202020204" pitchFamily="34" charset="0"/>
-              <a:buChar char="•"/>
-            </a:pPr>
+              <a:t>the problem</a:t>
+            </a:r>
             <a:endParaRPr lang="en-US" sz="2800" dirty="0">
               <a:latin typeface="Arial" pitchFamily="34" charset="0"/>
               <a:cs typeface="Arial" pitchFamily="34" charset="0"/>

</xml_diff>